<commit_message>
Fix SmartArt timeline showing Jan-Sep instead of the real May-Oct span
The Roadmap & Timeline slide's background SmartArt had hardcoded
Italian month labels (Gennaio-Settembre) baked into the template,
completely independent of the date boxes we'd already fixed. Relabeled
the 6 real months to May-October (matching the actual program span)
and blanked the 3 extra slots rather than risk corrupting the
SmartArt's node/connection structure by deleting them outright.
</commit_message>
<xml_diff>
--- a/slides/AEGIS_Gate1_Official.pptx
+++ b/slides/AEGIS_Gate1_Official.pptx
@@ -1012,7 +1012,7 @@
         <a:p>
           <a:r>
             <a:rPr lang="it-IT"/>
-            <a:t>Marzo</a:t>
+            <a:t>July</a:t>
           </a:r>
         </a:p>
       </dgm:t>
@@ -1052,7 +1052,7 @@
         <a:p>
           <a:r>
             <a:rPr lang="it-IT"/>
-            <a:t>Aprile</a:t>
+            <a:t>August</a:t>
           </a:r>
         </a:p>
       </dgm:t>
@@ -1095,7 +1095,7 @@
             <a:rPr lang="it-IT">
               <a:latin typeface="TIM Sans"/>
             </a:rPr>
-            <a:t>Febbraio</a:t>
+            <a:t>June</a:t>
           </a:r>
           <a:endParaRPr lang="it-IT"/>
         </a:p>
@@ -1136,7 +1136,7 @@
         <a:p>
           <a:r>
             <a:rPr lang="it-IT"/>
-            <a:t>Maggio </a:t>
+            <a:t>September</a:t>
           </a:r>
         </a:p>
       </dgm:t>
@@ -1176,7 +1176,7 @@
         <a:p>
           <a:r>
             <a:rPr lang="it-IT"/>
-            <a:t>Giugno</a:t>
+            <a:t>October</a:t>
           </a:r>
         </a:p>
       </dgm:t>
@@ -1216,7 +1216,7 @@
         <a:p>
           <a:r>
             <a:rPr lang="it-IT"/>
-            <a:t>Luglio</a:t>
+            <a:t/>
           </a:r>
         </a:p>
       </dgm:t>
@@ -1256,7 +1256,7 @@
         <a:p>
           <a:r>
             <a:rPr lang="it-IT"/>
-            <a:t>Agosto </a:t>
+            <a:t/>
           </a:r>
         </a:p>
       </dgm:t>
@@ -1296,7 +1296,7 @@
         <a:p>
           <a:r>
             <a:rPr lang="it-IT"/>
-            <a:t>Settembre</a:t>
+            <a:t/>
           </a:r>
         </a:p>
       </dgm:t>
@@ -1335,7 +1335,7 @@
             <a:rPr lang="it-IT">
               <a:latin typeface="TIM Sans"/>
             </a:rPr>
-            <a:t>Gennaio</a:t>
+            <a:t>May</a:t>
           </a:r>
         </a:p>
       </dgm:t>
@@ -1630,7 +1630,7 @@
             <a:rPr lang="it-IT" sz="1300" kern="1200">
               <a:latin typeface="TIM Sans"/>
             </a:rPr>
-            <a:t>Gennaio</a:t>
+            <a:t>May</a:t>
           </a:r>
         </a:p>
       </dsp:txBody>
@@ -1705,7 +1705,7 @@
             <a:rPr lang="it-IT" sz="1300" kern="1200">
               <a:latin typeface="TIM Sans"/>
             </a:rPr>
-            <a:t>Febbraio</a:t>
+            <a:t>June</a:t>
           </a:r>
           <a:endParaRPr lang="it-IT" sz="1300" kern="1200"/>
         </a:p>
@@ -1779,7 +1779,7 @@
           </a:pPr>
           <a:r>
             <a:rPr lang="it-IT" sz="1300" kern="1200"/>
-            <a:t>Marzo</a:t>
+            <a:t>July</a:t>
           </a:r>
         </a:p>
       </dsp:txBody>
@@ -1852,7 +1852,7 @@
           </a:pPr>
           <a:r>
             <a:rPr lang="it-IT" sz="1300" kern="1200"/>
-            <a:t>Aprile</a:t>
+            <a:t>August</a:t>
           </a:r>
         </a:p>
       </dsp:txBody>
@@ -1925,7 +1925,7 @@
           </a:pPr>
           <a:r>
             <a:rPr lang="it-IT" sz="1300" kern="1200"/>
-            <a:t>Maggio </a:t>
+            <a:t>September</a:t>
           </a:r>
         </a:p>
       </dsp:txBody>
@@ -1998,7 +1998,7 @@
           </a:pPr>
           <a:r>
             <a:rPr lang="it-IT" sz="1300" kern="1200"/>
-            <a:t>Giugno</a:t>
+            <a:t>October</a:t>
           </a:r>
         </a:p>
       </dsp:txBody>
@@ -2071,7 +2071,7 @@
           </a:pPr>
           <a:r>
             <a:rPr lang="it-IT" sz="1300" kern="1200"/>
-            <a:t>Luglio</a:t>
+            <a:t/>
           </a:r>
         </a:p>
       </dsp:txBody>
@@ -2144,7 +2144,7 @@
           </a:pPr>
           <a:r>
             <a:rPr lang="it-IT" sz="1300" kern="1200"/>
-            <a:t>Agosto </a:t>
+            <a:t/>
           </a:r>
         </a:p>
       </dsp:txBody>
@@ -2217,7 +2217,7 @@
           </a:pPr>
           <a:r>
             <a:rPr lang="it-IT" sz="1300" kern="1200"/>
-            <a:t>Settembre</a:t>
+            <a:t/>
           </a:r>
         </a:p>
       </dsp:txBody>

</xml_diff>